<commit_message>
GreenWaste lab in every method session
The lab chart from Day 1 S3 now grows through the week, one method per
session, on the same invented GreenWaste where the true effect is -900:
- Oct13 S1 (DiD): adds difference-in-differences and the "joiners' costs
  already falling faster" slider, the parallel-trends assumption.
- Oct13 S2 (RDD): adds regression discontinuity and "something else
  changes at 58", the assumption Check 3 tests (manager age).
- Oct13 S3 (matching): adds matching; the measured slider cannot break it,
  the unmeasured one can.
- Oct14 S3 (QA clinic): all six methods and all five sliders as a recap
  before the analyst answers with the data.
The lab's one-line call is hidden on every slide, labels sit beside the
dots. Every slide of the five decks checked with live cells run; their
PDF and PowerPoint snapshots refreshed.

Co-Authored-By: Claude Opus 5.5 <noreply@anthropic.com>
</commit_message>
<xml_diff>
--- a/docs/exports/Oct13_session1.pptx
+++ b/docs/exports/Oct13_session1.pptx
@@ -38,6 +38,7 @@
     <p:sldId id="286" r:id="rId38"/>
     <p:sldId id="287" r:id="rId39"/>
     <p:sldId id="288" r:id="rId40"/>
+    <p:sldId id="289" r:id="rId41"/>
   </p:sldIdLst>
   <p:sldSz cx="12192000" cy="6858000" type="screen4x3"/>
   <p:notesSz cx="6858000" cy="9144000"/>
@@ -655,7 +656,17 @@
           <a:lstStyle/>
           <a:p>
             <a:r>
-              <a:t>Reminder for the room (vocab from Day 1 Session 1): the coefficient is the effect size, here in AED; the 95% confidence interval is the range of plausible true values, not a margin of certainty; the p-value is how surprising this result would be if the programme had truly done nothing. Walk row 4 first, then name rows 2 and 3 as the two numbers a careless report would quote instead. Facilitation question worth asking here: which row would you want on the front page of the briefing, and which two would a careless evaluator report?</a:t>
+              <a:t>Paper (Oct13_session1_materials.docx): Hand out “Which row is the impact?” (pack page 2, one per participant) now, after the hand calculation. Tell the room to leave question 4 until Section 4 (“What this data can and cannot show”).</a:t>
+            </a:r>
+          </a:p>
+          <a:p>
+            <a:r>
+              <a:t>Before running, point at the formula: round * enrolled gives the time indicator, the group indicator and their interaction (round:enrolled), and the clusters line clusters standard errors by neighbourhood.</a:t>
+            </a:r>
+          </a:p>
+          <a:p>
+            <a:r>
+              <a:t>Run the chunk live, then take a vote across the three coefficients. Many will pick enrolled because it is large and has the word “enrolled” in it; that is the trap the next slides unpack. The number in round:enrolled is the same -816 they got by hand.</a:t>
             </a:r>
           </a:p>
           <a:p/>
@@ -776,7 +787,7 @@
           <a:lstStyle/>
           <a:p>
             <a:r>
-              <a:t>Illustrative data, not GreenWaste. Point out that the groups move together before the dashed cut-off and only diverge after. Then contrast: GreenWaste has a single before-period, so the check cannot be run, which sets up the next slide.</a:t>
+              <a:t>Reminder for the room (vocab from Day 1 Session 1): the coefficient is the effect size, here in AED; the 95% confidence interval is the range of plausible true values, not a margin of certainty; the p-value is how surprising this result would be if the programme had truly done nothing. Walk row 4 first, then name rows 2 and 3 as the two numbers a careless report would quote instead. Facilitation question worth asking here: which row would you want on the front page of the briefing, and which two would a careless evaluator report?</a:t>
             </a:r>
           </a:p>
           <a:p/>
@@ -897,7 +908,7 @@
           <a:lstStyle/>
           <a:p>
             <a:r>
-              <a:t>Paper (Oct13_session1_materials.docx): the room now answers question 4 on “Which row is the impact?” (pack page 2). Take two or three answers to the ask before moving on; the next two slides give our list.</a:t>
+              <a:t>Illustrative data, not GreenWaste. Point out that the groups move together before the dashed cut-off and only diverge after. Then contrast: GreenWaste has a single before-period, so the check cannot be run, which sets up the next slide.</a:t>
             </a:r>
           </a:p>
           <a:p/>
@@ -1018,7 +1029,7 @@
           <a:lstStyle/>
           <a:p>
             <a:r>
-              <a:t>Recap: they built a balance table on Day 1 Session 3. It makes the parallel-trends point concrete, because the pre-trend test cannot be run on two-wave data. Land the ask: the result leans heavily on the assumption, and a recommendation should say so. Reminder for the room: the p-value answers “how surprising is this baseline gap if the two groups were really the same?”, so a tiny p-value is the worry here, not the reassurance.</a:t>
+              <a:t>Paper (Oct13_session1_materials.docx): the room now answers question 4 on “Which row is the impact?” (pack page 2). Take two or three answers to the ask before moving on; the next two slides give our list.</a:t>
             </a:r>
           </a:p>
           <a:p/>
@@ -1139,7 +1150,7 @@
           <a:lstStyle/>
           <a:p>
             <a:r>
-              <a:t>Paper (Oct13_session1_materials.docx): Hand out “AI Snapshot: explaining the table” (pack page 3, one per pair).</a:t>
+              <a:t>Recap: they built a balance table on Day 1 Session 3. It makes the parallel-trends point concrete, because the pre-trend test cannot be run on two-wave data. Land the ask: the result leans heavily on the assumption, and a recommendation should say so. Reminder for the room: the p-value answers “how surprising is this baseline gap if the two groups were really the same?”, so a tiny p-value is the worry here, not the reassurance.</a:t>
             </a:r>
           </a:p>
           <a:p/>
@@ -1260,7 +1271,7 @@
           <a:lstStyle/>
           <a:p>
             <a:r>
-              <a:t>OPTIONAL. If time is short, skip this slide and go straight to the questions on the next one. If you run it: give three minutes, then reveal the list and ask what the AI missed, what it added that is worth keeping, and whether anything it suggested was incorrect.</a:t>
+              <a:t>Paper (Oct13_session1_materials.docx): Hand out “AI Snapshot: explaining the table” (pack page 3, one per pair).</a:t>
             </a:r>
           </a:p>
           <a:p/>
@@ -1381,7 +1392,7 @@
           <a:lstStyle/>
           <a:p>
             <a:r>
-              <a:t>Paper (Oct13_session1_materials.docx): Hand out the take-away cards (pack page 4, cut into cards). Give a minute to fill in “On my desk”, then take two or three examples.</a:t>
+              <a:t>OPTIONAL. If time is short, skip this slide and go straight to the questions on the next one. If you run it: give three minutes, then reveal the list and ask what the AI missed, what it added that is worth keeping, and whether anything it suggested was incorrect.</a:t>
             </a:r>
           </a:p>
           <a:p/>
@@ -1502,6 +1513,127 @@
           <a:lstStyle/>
           <a:p>
             <a:r>
+              <a:t>Paper (Oct13_session1_materials.docx): Hand out the take-away cards (pack page 4, cut into cards). Give a minute to fill in “On my desk”, then take two or three examples.</a:t>
+            </a:r>
+          </a:p>
+          <a:p/>
+          <a:p>
+            <a:r>
+              <a:t>span.MJX_Assistive_MathML {</a:t>
+            </a:r>
+          </a:p>
+          <a:p>
+            <a:r>
+              <a:t>position:absolute!important;</a:t>
+            </a:r>
+          </a:p>
+          <a:p>
+            <a:r>
+              <a:t>clip: rect(1px, 1px, 1px, 1px);</a:t>
+            </a:r>
+          </a:p>
+          <a:p>
+            <a:r>
+              <a:t>padding: 1px 0 0 0!important;</a:t>
+            </a:r>
+          </a:p>
+          <a:p>
+            <a:r>
+              <a:t>border: 0!important;</a:t>
+            </a:r>
+          </a:p>
+          <a:p>
+            <a:r>
+              <a:t>height: 1px!important;</a:t>
+            </a:r>
+          </a:p>
+          <a:p>
+            <a:r>
+              <a:t>width: 1px!important;</a:t>
+            </a:r>
+          </a:p>
+          <a:p>
+            <a:r>
+              <a:t>overflow: hidden!important;</a:t>
+            </a:r>
+          </a:p>
+          <a:p>
+            <a:r>
+              <a:t>display:block!important;</a:t>
+            </a:r>
+          </a:p>
+          <a:p>
+            <a:r>
+              <a:t>}</a:t>
+            </a:r>
+          </a:p>
+        </p:txBody>
+      </p:sp>
+      <p:sp>
+        <p:nvSpPr>
+          <p:cNvPr id="4" name="Slide Number Placeholder 3"/>
+          <p:cNvSpPr>
+            <a:spLocks noGrp="1"/>
+          </p:cNvSpPr>
+          <p:nvPr>
+            <p:ph type="sldNum" idx="5" sz="quarter"/>
+          </p:nvPr>
+        </p:nvSpPr>
+        <p:spPr/>
+      </p:sp>
+    </p:spTree>
+  </p:cSld>
+  <p:clrMapOvr>
+    <a:masterClrMapping/>
+  </p:clrMapOvr>
+</p:notes>
+</file>
+
+<file path=ppt/notesSlides/notesSlide18.xml><?xml version="1.0" encoding="utf-8"?>
+<p:notes xmlns:a="http://schemas.openxmlformats.org/drawingml/2006/main" xmlns:p="http://schemas.openxmlformats.org/presentationml/2006/main" xmlns:r="http://schemas.openxmlformats.org/officeDocument/2006/relationships">
+  <p:cSld>
+    <p:spTree>
+      <p:nvGrpSpPr>
+        <p:cNvPr id="1" name=""/>
+        <p:cNvGrpSpPr/>
+        <p:nvPr/>
+      </p:nvGrpSpPr>
+      <p:grpSpPr>
+        <a:xfrm>
+          <a:off x="0" y="0"/>
+          <a:ext cx="0" cy="0"/>
+          <a:chOff x="0" y="0"/>
+          <a:chExt cx="0" cy="0"/>
+        </a:xfrm>
+      </p:grpSpPr>
+      <p:sp>
+        <p:nvSpPr>
+          <p:cNvPr id="2" name="Slide Image Placeholder 1"/>
+          <p:cNvSpPr>
+            <a:spLocks noGrp="1"/>
+          </p:cNvSpPr>
+          <p:nvPr>
+            <p:ph type="sldImg" idx="2"/>
+          </p:nvPr>
+        </p:nvSpPr>
+        <p:spPr/>
+      </p:sp>
+      <p:sp>
+        <p:nvSpPr>
+          <p:cNvPr id="3" name="Notes Placeholder 2"/>
+          <p:cNvSpPr>
+            <a:spLocks noGrp="1"/>
+          </p:cNvSpPr>
+          <p:nvPr>
+            <p:ph type="body" idx="3" sz="quarter"/>
+          </p:nvPr>
+        </p:nvSpPr>
+        <p:spPr/>
+        <p:txBody>
+          <a:bodyPr/>
+          <a:lstStyle/>
+          <a:p>
+            <a:r>
               <a:t>If there is time at the very end, ask the room: is there a different question you would ask AI to help you understand a concept from today? For example: “I am learning about impact evaluation to help me make policy decisions. How should I think about a confidence interval, and how is it relevant when I compare an estimate to a decision threshold?” Adding context about who you are and why you are asking usually gets a more useful answer.</a:t>
             </a:r>
           </a:p>
@@ -2233,7 +2365,7 @@
           <a:lstStyle/>
           <a:p>
             <a:r>
-              <a:t>Tie each item back to the minister sentence: “the change over time” needs items 2 and 4; “in a group that did not” needs item 3. Item 5 is a deliberate foreshadow of Section 4. Do not resolve it here.</a:t>
+              <a:t>About 5 minutes. All sliders start at zero, where every method sits on the truth. Take a prediction for each slider before moving it. Costs rising anyway moves only before-and-after; the two “joiners differ” sliders move only with-and-without; DiD stays on -900 for all three. The last slider (joiners’ costs already falling faster) pulls DiD away: that is the parallel-trends assumption, in one slider. The randomised comparison survives all four.</a:t>
             </a:r>
           </a:p>
           <a:p/>
@@ -2354,17 +2486,7 @@
           <a:lstStyle/>
           <a:p>
             <a:r>
-              <a:t>Press Run. Read one business across its two rows (business 11 went from about 1,308 to 240 AED) so the room sees “one row per business per round”. The counts table shows 2,964 businesses that took part and 1,995 that did not, each observed in both rounds (4,959 businesses in total).</a:t>
-            </a:r>
-          </a:p>
-          <a:p>
-            <a:r>
-              <a:t>If asked about tn: it is the businesses in the neighbourhoods where the programme was offered (treatment_neighborhood == 1). Within those, every business scoring below the eligibility cut-off of 58 enrolled and none above it did, so “did not take part” means the businesses above the cut-off. That is our comparison.</a:t>
-            </a:r>
-          </a:p>
-          <a:p>
-            <a:r>
-              <a:t>The warning sets up “What this data can and cannot show” in Section 4: with a single pre-period, parallel pre-trends cannot be tested.</a:t>
+              <a:t>Tie each item back to the minister sentence: “the change over time” needs items 2 and 4; “in a group that did not” needs item 3. Item 5 is a deliberate foreshadow of Section 4. Do not resolve it here.</a:t>
             </a:r>
           </a:p>
           <a:p/>
@@ -2485,17 +2607,17 @@
           <a:lstStyle/>
           <a:p>
             <a:r>
-              <a:t>Paper (Oct13_session1_materials.docx): Hand out “Which row is the impact?” (pack page 2, one per participant) now, after the hand calculation. Tell the room to leave question 4 until Section 4 (“What this data can and cannot show”).</a:t>
-            </a:r>
-          </a:p>
-          <a:p>
-            <a:r>
-              <a:t>Before running, point at the formula: round * enrolled gives the time indicator, the group indicator and their interaction (round:enrolled), and the clusters line clusters standard errors by neighbourhood.</a:t>
-            </a:r>
-          </a:p>
-          <a:p>
-            <a:r>
-              <a:t>Run the chunk live, then take a vote across the three coefficients. Many will pick enrolled because it is large and has the word “enrolled” in it; that is the trap the next slides unpack. The number in round:enrolled is the same -816 they got by hand.</a:t>
+              <a:t>Press Run. Read one business across its two rows (business 11 went from about 1,308 to 240 AED) so the room sees “one row per business per round”. The counts table shows 2,964 businesses that took part and 1,995 that did not, each observed in both rounds (4,959 businesses in total).</a:t>
+            </a:r>
+          </a:p>
+          <a:p>
+            <a:r>
+              <a:t>If asked about tn: it is the businesses in the neighbourhoods where the programme was offered (treatment_neighborhood == 1). Within those, every business scoring below the eligibility cut-off of 58 enrolled and none above it did, so “did not take part” means the businesses above the cut-off. That is our comparison.</a:t>
+            </a:r>
+          </a:p>
+          <a:p>
+            <a:r>
+              <a:t>The warning sets up “What this data can and cannot show” in Section 4: with a single pre-period, parallel pre-trends cannot be tested.</a:t>
             </a:r>
           </a:p>
           <a:p/>
@@ -6676,6 +6798,48 @@
 </p:sld>
 </file>
 
+<file path=ppt/slides/slide34.xml><?xml version="1.0" encoding="utf-8"?>
+<p:sld xmlns:a="http://schemas.openxmlformats.org/drawingml/2006/main" xmlns:p="http://schemas.openxmlformats.org/presentationml/2006/main" xmlns:r="http://schemas.openxmlformats.org/officeDocument/2006/relationships">
+  <p:cSld>
+    <p:spTree>
+      <p:nvGrpSpPr>
+        <p:cNvPr id="1" name=""/>
+        <p:cNvGrpSpPr/>
+        <p:nvPr/>
+      </p:nvGrpSpPr>
+      <p:grpSpPr/>
+      <p:pic>
+        <p:nvPicPr>
+          <p:cNvPr id="2" name="Picture 1" descr="s034.jpg"/>
+          <p:cNvPicPr>
+            <a:picLocks noChangeAspect="1"/>
+          </p:cNvPicPr>
+          <p:nvPr/>
+        </p:nvPicPr>
+        <p:blipFill>
+          <a:blip r:embed="rId2"/>
+          <a:stretch>
+            <a:fillRect/>
+          </a:stretch>
+        </p:blipFill>
+        <p:spPr>
+          <a:xfrm>
+            <a:off x="0" y="0"/>
+            <a:ext cx="12192000" cy="6858000"/>
+          </a:xfrm>
+          <a:prstGeom prst="rect">
+            <a:avLst/>
+          </a:prstGeom>
+        </p:spPr>
+      </p:pic>
+    </p:spTree>
+  </p:cSld>
+  <p:clrMapOvr>
+    <a:masterClrMapping/>
+  </p:clrMapOvr>
+</p:sld>
+</file>
+
 <file path=ppt/slides/slide4.xml><?xml version="1.0" encoding="utf-8"?>
 <p:sld xmlns:a="http://schemas.openxmlformats.org/drawingml/2006/main" xmlns:p="http://schemas.openxmlformats.org/presentationml/2006/main" xmlns:r="http://schemas.openxmlformats.org/officeDocument/2006/relationships">
   <p:cSld>

</xml_diff>